<commit_message>
Update Lab1 Workbook-Tool Installation.pptx
</commit_message>
<xml_diff>
--- a/Lab1/Lab1 Workbook-Tool Installation.pptx
+++ b/Lab1/Lab1 Workbook-Tool Installation.pptx
@@ -15556,13 +15556,13 @@
           <a:p>
             <a:r>
               <a:rPr lang="en-US" dirty="0"/>
-              <a:t>Verilog folder:(</a:t>
+              <a:t>Verilog folder: (</a:t>
             </a:r>
             <a:r>
               <a:rPr lang="en-US" dirty="0">
                 <a:hlinkClick r:id="rId2"/>
               </a:rPr>
-              <a:t>https://github.com/roo-nju/hkust-soc-lab/Lab1/Verilog</a:t>
+              <a:t>https://github.com/roo-nju/hkust-soc-lab/tree/main/Lab1/Verilog</a:t>
             </a:r>
             <a:r>
               <a:rPr lang="en-US" dirty="0"/>

</xml_diff>